<commit_message>
docs(projeto-final): deixa o roteiro mais humano e focado nas extensoes
Reescreve as falas do roteiro num tom de conversa, sem jargao tecnico
sem explicacao, e ajusta os slides pra combinar (menos codigo/BNF,
mais exemplos do tipo "antes e depois" mostrando o que cada extensao
muda na pratica).
</commit_message>
<xml_diff>
--- a/apresentacao-projeto-final/apresentacao.pptx
+++ b/apresentacao-projeto-final/apresentacao.pptx
@@ -3599,7 +3599,7 @@
                 </a:solidFill>
                 <a:latin typeface="Calibri"/>
               </a:rPr>
-              <a:t>As três extensões juntas</a:t>
+              <a:t>Mostrando tudo funcionando junto</a:t>
             </a:r>
           </a:p>
         </p:txBody>
@@ -4481,7 +4481,7 @@
                 </a:solidFill>
                 <a:latin typeface="Calibri"/>
               </a:rPr>
-              <a:t>Validação</a:t>
+              <a:t>Confiança</a:t>
             </a:r>
           </a:p>
         </p:txBody>
@@ -4516,7 +4516,7 @@
                 </a:solidFill>
                 <a:latin typeface="Calibri"/>
               </a:rPr>
-              <a:t>Testes</a:t>
+              <a:t>E continua tudo funcionando como antes</a:t>
             </a:r>
           </a:p>
         </p:txBody>
@@ -4530,7 +4530,7 @@
         <p:spPr>
           <a:xfrm>
             <a:off x="548640" y="1828800"/>
-            <a:ext cx="11094415" cy="731520"/>
+            <a:ext cx="11094415" cy="822960"/>
           </a:xfrm>
           <a:prstGeom prst="rect">
             <a:avLst/>
@@ -4552,10 +4552,13 @@
               </a:spcAft>
             </a:pPr>
             <a:r>
-              <a:rPr sz="1700" b="0" i="0">
-                <a:latin typeface="Calibri"/>
-              </a:rPr>
-              <a:t>40 testes da Atividade 10 continuam passando sem nenhuma alteração — zero regressão.</a:t>
+              <a:rPr sz="1800" b="1" i="0">
+                <a:solidFill>
+                  <a:srgbClr val="1F3A5F"/>
+                </a:solidFill>
+                <a:latin typeface="Calibri"/>
+              </a:rPr>
+              <a:t>O mais importante: a gente não quebrou nada do que já existia.</a:t>
             </a:r>
           </a:p>
         </p:txBody>
@@ -4568,7 +4571,7 @@
         </p:nvSpPr>
         <p:spPr>
           <a:xfrm>
-            <a:off x="548640" y="2651760"/>
+            <a:off x="548640" y="2743200"/>
             <a:ext cx="11094415" cy="1920240"/>
           </a:xfrm>
           <a:prstGeom prst="rect">
@@ -4610,7 +4613,7 @@
         </p:nvSpPr>
         <p:spPr>
           <a:xfrm>
-            <a:off x="713232" y="2816352"/>
+            <a:off x="713232" y="2907792"/>
             <a:ext cx="10765231" cy="1591056"/>
           </a:xfrm>
           <a:prstGeom prst="rect">
@@ -4728,8 +4731,8 @@
         </p:nvSpPr>
         <p:spPr>
           <a:xfrm>
-            <a:off x="548640" y="4846320"/>
-            <a:ext cx="11094415" cy="1645920"/>
+            <a:off x="548640" y="4937760"/>
+            <a:ext cx="11094415" cy="1463040"/>
           </a:xfrm>
           <a:prstGeom prst="rect">
             <a:avLst/>
@@ -4755,7 +4758,7 @@
               <a:rPr sz="1600" b="0" i="0">
                 <a:latin typeface="Calibri"/>
               </a:rPr>
-              <a:t>+26 testes novos cobrindo as três extensões, incluindo um caso combinado e return antecipado dentro de recursão.</a:t>
+              <a:t>Todos os testes de antes continuam passando do mesmo jeito.</a:t>
             </a:r>
           </a:p>
           <a:p>
@@ -4775,7 +4778,7 @@
                 </a:solidFill>
                 <a:latin typeface="Calibri"/>
               </a:rPr>
-              <a:t>O simulador de equivalência semântica (que já pegou 2 bugs reais na Atividade 10) só precisou de 3 linhas novas — setle/setge/setne.</a:t>
+              <a:t>E escrevemos vários testes novos só pras três coisas que adicionamos.</a:t>
             </a:r>
           </a:p>
         </p:txBody>
@@ -4940,7 +4943,7 @@
                 </a:solidFill>
                 <a:latin typeface="Calibri"/>
               </a:rPr>
-              <a:t>Escopo</a:t>
+              <a:t>Pra fechar</a:t>
             </a:r>
           </a:p>
         </p:txBody>
@@ -4975,7 +4978,7 @@
                 </a:solidFill>
                 <a:latin typeface="Calibri"/>
               </a:rPr>
-              <a:t>O que ficou de fora</a:t>
+              <a:t>Por que só essas três</a:t>
             </a:r>
           </a:p>
         </p:txBody>
@@ -4989,7 +4992,7 @@
         <p:spPr>
           <a:xfrm>
             <a:off x="548640" y="2011680"/>
-            <a:ext cx="11094415" cy="914400"/>
+            <a:ext cx="11094415" cy="1097280"/>
           </a:xfrm>
           <a:prstGeom prst="rect">
             <a:avLst/>
@@ -5011,10 +5014,10 @@
               </a:spcAft>
             </a:pPr>
             <a:r>
-              <a:rPr sz="1700" b="0" i="0">
-                <a:latin typeface="Calibri"/>
-              </a:rPr>
-              <a:t>Enunciado: 1 extensão média/alta OU pelo menos 3 simples — escolhemos 3 simples.</a:t>
+              <a:rPr sz="1800" b="0" i="0">
+                <a:latin typeface="Calibri"/>
+              </a:rPr>
+              <a:t>O enunciado dava a opção de fazer uma coisa mais complexa, ou pelo menos três mais simples. A gente preferiu as três simples.</a:t>
             </a:r>
           </a:p>
         </p:txBody>
@@ -5027,8 +5030,117 @@
         </p:nvSpPr>
         <p:spPr>
           <a:xfrm>
-            <a:off x="548640" y="3017520"/>
-            <a:ext cx="5272887" cy="365760"/>
+            <a:off x="548640" y="3383280"/>
+            <a:ext cx="11094415" cy="2377440"/>
+          </a:xfrm>
+          <a:prstGeom prst="rect">
+            <a:avLst/>
+          </a:prstGeom>
+          <a:noFill/>
+        </p:spPr>
+        <p:txBody>
+          <a:bodyPr wrap="square" lIns="0" rIns="0" tIns="0" bIns="0">
+            <a:spAutoFit/>
+          </a:bodyPr>
+          <a:lstStyle/>
+          <a:p>
+            <a:pPr algn="l" indent="-228600" marL="228600" lvl="0">
+              <a:lnSpc>
+                <a:spcPct val="130000"/>
+              </a:lnSpc>
+              <a:spcAft>
+                <a:spcPts val="400"/>
+              </a:spcAft>
+              <a:buChar char="•"/>
+            </a:pPr>
+            <a:r>
+              <a:rPr sz="1800" b="0" i="0">
+                <a:latin typeface="Calibri"/>
+              </a:rPr>
+              <a:t>Comparações novas</a:t>
+            </a:r>
+          </a:p>
+          <a:p>
+            <a:pPr algn="l" indent="-228600" marL="228600" lvl="0">
+              <a:lnSpc>
+                <a:spcPct val="130000"/>
+              </a:lnSpc>
+              <a:spcAft>
+                <a:spcPts val="400"/>
+              </a:spcAft>
+              <a:buChar char="•"/>
+            </a:pPr>
+            <a:r>
+              <a:rPr sz="1800" b="0" i="0">
+                <a:latin typeface="Calibri"/>
+              </a:rPr>
+              <a:t>Atalho pra atualizar variáveis</a:t>
+            </a:r>
+          </a:p>
+          <a:p>
+            <a:pPr algn="l" indent="-228600" marL="228600" lvl="0">
+              <a:lnSpc>
+                <a:spcPct val="130000"/>
+              </a:lnSpc>
+              <a:spcAft>
+                <a:spcPts val="400"/>
+              </a:spcAft>
+              <a:buChar char="•"/>
+            </a:pPr>
+            <a:r>
+              <a:rPr sz="1800" b="0" i="0">
+                <a:latin typeface="Calibri"/>
+              </a:rPr>
+              <a:t>Sair de uma função mais cedo</a:t>
+            </a:r>
+          </a:p>
+          <a:p>
+            <a:pPr algn="l">
+              <a:lnSpc>
+                <a:spcPct val="130000"/>
+              </a:lnSpc>
+              <a:spcAft>
+                <a:spcPts val="400"/>
+              </a:spcAft>
+            </a:pPr>
+            <a:r>
+              <a:rPr sz="1000" b="0" i="0">
+                <a:latin typeface="Calibri"/>
+              </a:rPr>
+              <a:t/>
+            </a:r>
+          </a:p>
+          <a:p>
+            <a:pPr algn="l">
+              <a:lnSpc>
+                <a:spcPct val="130000"/>
+              </a:lnSpc>
+              <a:spcAft>
+                <a:spcPts val="400"/>
+              </a:spcAft>
+            </a:pPr>
+            <a:r>
+              <a:rPr sz="1700" b="0" i="1">
+                <a:solidFill>
+                  <a:srgbClr val="666666"/>
+                </a:solidFill>
+                <a:latin typeface="Calibri"/>
+              </a:rPr>
+              <a:t>São mudanças que ajudam de verdade quem for programar na linguagem — e deu pra testar tudo com calma.</a:t>
+            </a:r>
+          </a:p>
+        </p:txBody>
+      </p:sp>
+      <p:sp>
+        <p:nvSpPr>
+          <p:cNvPr id="7" name="TextBox 6"/>
+          <p:cNvSpPr txBox="1"/>
+          <p:nvPr/>
+        </p:nvSpPr>
+        <p:spPr>
+          <a:xfrm>
+            <a:off x="11414455" y="6492240"/>
+            <a:ext cx="548640" cy="274320"/>
           </a:xfrm>
           <a:prstGeom prst="rect">
             <a:avLst/>
@@ -5041,89 +5153,15 @@
           </a:bodyPr>
           <a:lstStyle/>
           <a:p>
-            <a:pPr algn="l"/>
-            <a:r>
-              <a:rPr sz="1500" b="1" i="0">
-                <a:solidFill>
-                  <a:srgbClr val="2E8B57"/>
-                </a:solidFill>
-                <a:latin typeface="Calibri"/>
-              </a:rPr>
-              <a:t>Escolhidas</a:t>
-            </a:r>
-          </a:p>
-        </p:txBody>
-      </p:sp>
-      <p:sp>
-        <p:nvSpPr>
-          <p:cNvPr id="7" name="TextBox 6"/>
-          <p:cNvSpPr txBox="1"/>
-          <p:nvPr/>
-        </p:nvSpPr>
-        <p:spPr>
-          <a:xfrm>
-            <a:off x="548640" y="3474720"/>
-            <a:ext cx="5272887" cy="2286000"/>
-          </a:xfrm>
-          <a:prstGeom prst="rect">
-            <a:avLst/>
-          </a:prstGeom>
-          <a:noFill/>
-        </p:spPr>
-        <p:txBody>
-          <a:bodyPr wrap="square" lIns="0" rIns="0" tIns="0" bIns="0">
-            <a:spAutoFit/>
-          </a:bodyPr>
-          <a:lstStyle/>
-          <a:p>
-            <a:pPr algn="l" indent="-228600" marL="228600" lvl="0">
-              <a:lnSpc>
-                <a:spcPct val="115000"/>
-              </a:lnSpc>
-              <a:spcAft>
-                <a:spcPts val="400"/>
-              </a:spcAft>
-              <a:buChar char="•"/>
-            </a:pPr>
-            <a:r>
-              <a:rPr sz="1600" b="0" i="0">
-                <a:latin typeface="Calibri"/>
-              </a:rPr>
-              <a:t>&lt;=, &gt;=, !=</a:t>
-            </a:r>
-          </a:p>
-          <a:p>
-            <a:pPr algn="l" indent="-228600" marL="228600" lvl="0">
-              <a:lnSpc>
-                <a:spcPct val="115000"/>
-              </a:lnSpc>
-              <a:spcAft>
-                <a:spcPts val="400"/>
-              </a:spcAft>
-              <a:buChar char="•"/>
-            </a:pPr>
-            <a:r>
-              <a:rPr sz="1600" b="0" i="0">
-                <a:latin typeface="Calibri"/>
-              </a:rPr>
-              <a:t>+=, -=, *=, /=</a:t>
-            </a:r>
-          </a:p>
-          <a:p>
-            <a:pPr algn="l" indent="-228600" marL="228600" lvl="0">
-              <a:lnSpc>
-                <a:spcPct val="115000"/>
-              </a:lnSpc>
-              <a:spcAft>
-                <a:spcPts val="400"/>
-              </a:spcAft>
-              <a:buChar char="•"/>
-            </a:pPr>
-            <a:r>
-              <a:rPr sz="1600" b="0" i="0">
-                <a:latin typeface="Calibri"/>
-              </a:rPr>
-              <a:t>return como comando</a:t>
+            <a:pPr algn="r"/>
+            <a:r>
+              <a:rPr sz="1000" b="0" i="0">
+                <a:solidFill>
+                  <a:srgbClr val="666666"/>
+                </a:solidFill>
+                <a:latin typeface="Calibri"/>
+              </a:rPr>
+              <a:t>12/13</a:t>
             </a:r>
           </a:p>
         </p:txBody>
@@ -5131,179 +5169,6 @@
       <p:sp>
         <p:nvSpPr>
           <p:cNvPr id="8" name="TextBox 7"/>
-          <p:cNvSpPr txBox="1"/>
-          <p:nvPr/>
-        </p:nvSpPr>
-        <p:spPr>
-          <a:xfrm>
-            <a:off x="6370167" y="3017520"/>
-            <a:ext cx="5272887" cy="365760"/>
-          </a:xfrm>
-          <a:prstGeom prst="rect">
-            <a:avLst/>
-          </a:prstGeom>
-          <a:noFill/>
-        </p:spPr>
-        <p:txBody>
-          <a:bodyPr wrap="square" anchor="t" lIns="0" rIns="0" tIns="0" bIns="0">
-            <a:spAutoFit/>
-          </a:bodyPr>
-          <a:lstStyle/>
-          <a:p>
-            <a:pPr algn="l"/>
-            <a:r>
-              <a:rPr sz="1500" b="1" i="0">
-                <a:solidFill>
-                  <a:srgbClr val="666666"/>
-                </a:solidFill>
-                <a:latin typeface="Calibri"/>
-              </a:rPr>
-              <a:t>Não escolhidas (fora de escopo)</a:t>
-            </a:r>
-          </a:p>
-        </p:txBody>
-      </p:sp>
-      <p:sp>
-        <p:nvSpPr>
-          <p:cNvPr id="9" name="TextBox 8"/>
-          <p:cNvSpPr txBox="1"/>
-          <p:nvPr/>
-        </p:nvSpPr>
-        <p:spPr>
-          <a:xfrm>
-            <a:off x="6370167" y="3474720"/>
-            <a:ext cx="5272887" cy="2286000"/>
-          </a:xfrm>
-          <a:prstGeom prst="rect">
-            <a:avLst/>
-          </a:prstGeom>
-          <a:noFill/>
-        </p:spPr>
-        <p:txBody>
-          <a:bodyPr wrap="square" lIns="0" rIns="0" tIns="0" bIns="0">
-            <a:spAutoFit/>
-          </a:bodyPr>
-          <a:lstStyle/>
-          <a:p>
-            <a:pPr algn="l" indent="-228600" marL="228600" lvl="0">
-              <a:lnSpc>
-                <a:spcPct val="115000"/>
-              </a:lnSpc>
-              <a:spcAft>
-                <a:spcPts val="400"/>
-              </a:spcAft>
-              <a:buChar char="•"/>
-            </a:pPr>
-            <a:r>
-              <a:rPr sz="1600" b="0" i="0">
-                <a:solidFill>
-                  <a:srgbClr val="666666"/>
-                </a:solidFill>
-                <a:latin typeface="Calibri"/>
-              </a:rPr>
-              <a:t>Operadores lógicos (E, OU, NÃO)</a:t>
-            </a:r>
-          </a:p>
-          <a:p>
-            <a:pPr algn="l" indent="-228600" marL="228600" lvl="0">
-              <a:lnSpc>
-                <a:spcPct val="115000"/>
-              </a:lnSpc>
-              <a:spcAft>
-                <a:spcPts val="400"/>
-              </a:spcAft>
-              <a:buChar char="•"/>
-            </a:pPr>
-            <a:r>
-              <a:rPr sz="1600" b="0" i="0">
-                <a:solidFill>
-                  <a:srgbClr val="666666"/>
-                </a:solidFill>
-                <a:latin typeface="Calibri"/>
-              </a:rPr>
-              <a:t>Strings e booleanos como tipo</a:t>
-            </a:r>
-          </a:p>
-          <a:p>
-            <a:pPr algn="l" indent="-228600" marL="228600" lvl="0">
-              <a:lnSpc>
-                <a:spcPct val="115000"/>
-              </a:lnSpc>
-              <a:spcAft>
-                <a:spcPts val="400"/>
-              </a:spcAft>
-              <a:buChar char="•"/>
-            </a:pPr>
-            <a:r>
-              <a:rPr sz="1600" b="0" i="0">
-                <a:solidFill>
-                  <a:srgbClr val="666666"/>
-                </a:solidFill>
-                <a:latin typeface="Calibri"/>
-              </a:rPr>
-              <a:t>Funções primitivas pré-definidas</a:t>
-            </a:r>
-          </a:p>
-          <a:p>
-            <a:pPr algn="l" indent="-228600" marL="228600" lvl="0">
-              <a:lnSpc>
-                <a:spcPct val="115000"/>
-              </a:lnSpc>
-              <a:spcAft>
-                <a:spcPts val="400"/>
-              </a:spcAft>
-              <a:buChar char="•"/>
-            </a:pPr>
-            <a:r>
-              <a:rPr sz="1600" b="0" i="0">
-                <a:solidFill>
-                  <a:srgbClr val="666666"/>
-                </a:solidFill>
-                <a:latin typeface="Calibri"/>
-              </a:rPr>
-              <a:t>Qualquer extensão média/alta</a:t>
-            </a:r>
-          </a:p>
-        </p:txBody>
-      </p:sp>
-      <p:sp>
-        <p:nvSpPr>
-          <p:cNvPr id="10" name="TextBox 9"/>
-          <p:cNvSpPr txBox="1"/>
-          <p:nvPr/>
-        </p:nvSpPr>
-        <p:spPr>
-          <a:xfrm>
-            <a:off x="11414455" y="6492240"/>
-            <a:ext cx="548640" cy="274320"/>
-          </a:xfrm>
-          <a:prstGeom prst="rect">
-            <a:avLst/>
-          </a:prstGeom>
-          <a:noFill/>
-        </p:spPr>
-        <p:txBody>
-          <a:bodyPr wrap="square" anchor="t" lIns="0" rIns="0" tIns="0" bIns="0">
-            <a:spAutoFit/>
-          </a:bodyPr>
-          <a:lstStyle/>
-          <a:p>
-            <a:pPr algn="r"/>
-            <a:r>
-              <a:rPr sz="1000" b="0" i="0">
-                <a:solidFill>
-                  <a:srgbClr val="666666"/>
-                </a:solidFill>
-                <a:latin typeface="Calibri"/>
-              </a:rPr>
-              <a:t>12/13</a:t>
-            </a:r>
-          </a:p>
-        </p:txBody>
-      </p:sp>
-      <p:sp>
-        <p:nvSpPr>
-          <p:cNvPr id="11" name="TextBox 10"/>
           <p:cNvSpPr txBox="1"/>
           <p:nvPr/>
         </p:nvSpPr>
@@ -5757,7 +5622,7 @@
                 </a:solidFill>
                 <a:latin typeface="Calibri"/>
               </a:rPr>
-              <a:t>O que mudou desde o Marco 1</a:t>
+              <a:t>De onde a gente partiu</a:t>
             </a:r>
           </a:p>
         </p:txBody>
@@ -5810,8 +5675,8 @@
                 </a:solidFill>
                 <a:latin typeface="Calibri"/>
               </a:rPr>
-              <a:t>EC1
-(Marco 1)</a:t>
+              <a:t>Marco 1
+só expressões</a:t>
             </a:r>
           </a:p>
         </p:txBody>
@@ -5907,8 +5772,8 @@
                 </a:solidFill>
                 <a:latin typeface="Calibri"/>
               </a:rPr>
-              <a:t>EC2 (07)
-precedência</a:t>
+              <a:t>Depois
+variáveis</a:t>
             </a:r>
           </a:p>
         </p:txBody>
@@ -6004,8 +5869,8 @@
                 </a:solidFill>
                 <a:latin typeface="Calibri"/>
               </a:rPr>
-              <a:t>EV (08)
-variáveis</a:t>
+              <a:t>Depois
+if / while</a:t>
             </a:r>
           </a:p>
         </p:txBody>
@@ -6101,8 +5966,8 @@
                 </a:solidFill>
                 <a:latin typeface="Calibri"/>
               </a:rPr>
-              <a:t>Cmd (09)
-Turing-completa</a:t>
+              <a:t>Atividade 10
+funções</a:t>
             </a:r>
           </a:p>
         </p:txBody>
@@ -6198,8 +6063,8 @@
                 </a:solidFill>
                 <a:latin typeface="Calibri"/>
               </a:rPr>
-              <a:t>Fun (10)
-funções</a:t>
+              <a:t>Agora
+Projeto Final</a:t>
             </a:r>
           </a:p>
         </p:txBody>
@@ -6236,10 +6101,10 @@
               <a:buChar char="•"/>
             </a:pPr>
             <a:r>
-              <a:rPr sz="1600" b="0" i="0">
-                <a:latin typeface="Calibri"/>
-              </a:rPr>
-              <a:t>07 — Precedência: exp_a/exp_m tiram a obrigação de parentizar tudo.</a:t>
+              <a:rPr sz="1700" b="0" i="0">
+                <a:latin typeface="Calibri"/>
+              </a:rPr>
+              <a:t>No Marco 1, o compilador só entendia contas com números.</a:t>
             </a:r>
           </a:p>
           <a:p>
@@ -6253,10 +6118,10 @@
               <a:buChar char="•"/>
             </a:pPr>
             <a:r>
-              <a:rPr sz="1600" b="0" i="0">
-                <a:latin typeface="Calibri"/>
-              </a:rPr>
-              <a:t>08 — Variáveis + primeira análise semântica de verdade (tabela de símbolos).</a:t>
+              <a:rPr sz="1700" b="0" i="0">
+                <a:latin typeface="Calibri"/>
+              </a:rPr>
+              <a:t>Depois foi ganhando variáveis, if, while — até virar uma linguagem de verdade.</a:t>
             </a:r>
           </a:p>
           <a:p>
@@ -6270,10 +6135,10 @@
               <a:buChar char="•"/>
             </a:pPr>
             <a:r>
-              <a:rPr sz="1600" b="0" i="0">
-                <a:latin typeface="Calibri"/>
-              </a:rPr>
-              <a:t>09 — Condicionais, laços e comparações: Cmd é a primeira linguagem Turing-completa da série.</a:t>
+              <a:rPr sz="1700" b="0" i="0">
+                <a:latin typeface="Calibri"/>
+              </a:rPr>
+              <a:t>Na última atividade, chegamos em funções: com parâmetros e até recursão.</a:t>
             </a:r>
           </a:p>
           <a:p>
@@ -6287,30 +6152,13 @@
               <a:buChar char="•"/>
             </a:pPr>
             <a:r>
-              <a:rPr sz="1600" b="0" i="0">
-                <a:latin typeface="Calibri"/>
-              </a:rPr>
-              <a:t>10 — Funções: parâmetros, variáveis locais, recursão direta, convenção de chamada em pilha com RBP.</a:t>
-            </a:r>
-          </a:p>
-          <a:p>
-            <a:pPr algn="l" indent="-228600" marL="228600" lvl="0">
-              <a:lnSpc>
-                <a:spcPct val="115000"/>
-              </a:lnSpc>
-              <a:spcAft>
-                <a:spcPts val="400"/>
-              </a:spcAft>
-              <a:buChar char="•"/>
-            </a:pPr>
-            <a:r>
-              <a:rPr sz="1600" b="1" i="0">
+              <a:rPr sz="1700" b="1" i="0">
                 <a:solidFill>
                   <a:srgbClr val="2E8B57"/>
                 </a:solidFill>
                 <a:latin typeface="Calibri"/>
               </a:rPr>
-              <a:t>Projeto Final — parte exatamente daqui.</a:t>
+              <a:t>O Projeto Final é a gente melhorando esse compilador de funções.</a:t>
             </a:r>
           </a:p>
         </p:txBody>
@@ -6475,7 +6323,7 @@
                 </a:solidFill>
                 <a:latin typeface="Calibri"/>
               </a:rPr>
-              <a:t>Ponto de partida</a:t>
+              <a:t>As novidades</a:t>
             </a:r>
           </a:p>
         </p:txBody>
@@ -6510,7 +6358,7 @@
                 </a:solidFill>
                 <a:latin typeface="Calibri"/>
               </a:rPr>
-              <a:t>A linguagem Fun, rapidamente</a:t>
+              <a:t>O que a gente escolheu adicionar</a:t>
             </a:r>
           </a:p>
         </p:txBody>
@@ -6545,7 +6393,7 @@
                 </a:solidFill>
                 <a:latin typeface="Calibri"/>
               </a:rPr>
-              <a:t>Exemplo (Atividade 10)</a:t>
+              <a:t>Um programa em Fun</a:t>
             </a:r>
           </a:p>
         </p:txBody>
@@ -6816,7 +6664,7 @@
                 </a:solidFill>
                 <a:latin typeface="Calibri"/>
               </a:rPr>
-              <a:t>As três extensões escolhidas</a:t>
+              <a:t>As três coisas que adicionamos</a:t>
             </a:r>
           </a:p>
         </p:txBody>
@@ -6856,7 +6704,7 @@
               <a:rPr sz="1700" b="0" i="0">
                 <a:latin typeface="Calibri"/>
               </a:rPr>
-              <a:t>1. Comparações novas: &lt;=, &gt;=, !=</a:t>
+              <a:t>1. Comparações novas (menor ou igual, etc.)</a:t>
             </a:r>
           </a:p>
           <a:p>
@@ -6873,7 +6721,7 @@
               <a:rPr sz="1700" b="0" i="0">
                 <a:latin typeface="Calibri"/>
               </a:rPr>
-              <a:t>2. Atribuição composta: +=, -=, *=, /=</a:t>
+              <a:t>2. Um atalho pra atualizar variáveis (+=, -=...)</a:t>
             </a:r>
           </a:p>
           <a:p>
@@ -6890,7 +6738,7 @@
               <a:rPr sz="1700" b="0" i="0">
                 <a:latin typeface="Calibri"/>
               </a:rPr>
-              <a:t>3. return como comando (retorno antecipado)</a:t>
+              <a:t>3. Sair de uma função mais cedo com return</a:t>
             </a:r>
           </a:p>
           <a:p>
@@ -6925,7 +6773,7 @@
                 </a:solidFill>
                 <a:latin typeface="Calibri"/>
               </a:rPr>
-              <a:t>Critério: nenhuma exige tipo novo — escopo contido, toda a base de Fun continua funcionando sem regressão.</a:t>
+              <a:t>Todas deixam a linguagem mais fácil de usar no dia a dia, sem mudar nada do que já funcionava.</a:t>
             </a:r>
           </a:p>
         </p:txBody>
@@ -7125,7 +6973,7 @@
                 </a:solidFill>
                 <a:latin typeface="Calibri"/>
               </a:rPr>
-              <a:t>Novos operadores de comparação</a:t>
+              <a:t>Comparações novas</a:t>
             </a:r>
           </a:p>
         </p:txBody>
@@ -7139,7 +6987,7 @@
         <p:spPr>
           <a:xfrm>
             <a:off x="548640" y="1828800"/>
-            <a:ext cx="11094415" cy="640080"/>
+            <a:ext cx="11094415" cy="822960"/>
           </a:xfrm>
           <a:prstGeom prst="rect">
             <a:avLst/>
@@ -7161,10 +7009,10 @@
               </a:spcAft>
             </a:pPr>
             <a:r>
-              <a:rPr sz="1700" b="0" i="0">
-                <a:latin typeface="Calibri"/>
-              </a:rPr>
-              <a:t>&lt;=, &gt;= e != — mesmo lookahead de 1 caractere já usado para == desde a Atividade 09.</a:t>
+              <a:rPr sz="1800" b="0" i="0">
+                <a:latin typeface="Calibri"/>
+              </a:rPr>
+              <a:t>A linguagem já tinha 'menor que', 'maior que' e 'igual'. Faltavam três bem comuns:</a:t>
             </a:r>
           </a:p>
         </p:txBody>
@@ -7177,8 +7025,8 @@
         </p:nvSpPr>
         <p:spPr>
           <a:xfrm>
-            <a:off x="548640" y="2560320"/>
-            <a:ext cx="6400800" cy="2377440"/>
+            <a:off x="548640" y="2651760"/>
+            <a:ext cx="6035040" cy="2194560"/>
           </a:xfrm>
           <a:prstGeom prst="rect">
             <a:avLst/>
@@ -7219,8 +7067,8 @@
         </p:nvSpPr>
         <p:spPr>
           <a:xfrm>
-            <a:off x="713232" y="2724912"/>
-            <a:ext cx="6071616" cy="2048256"/>
+            <a:off x="713232" y="2816352"/>
+            <a:ext cx="5705856" cy="1865376"/>
           </a:xfrm>
           <a:prstGeom prst="rect">
             <a:avLst/>
@@ -7242,13 +7090,13 @@
               </a:spcAft>
             </a:pPr>
             <a:r>
-              <a:rPr sz="1400" b="0" i="0">
+              <a:rPr sz="2000" b="0" i="0">
                 <a:solidFill>
                   <a:srgbClr val="222222"/>
                 </a:solidFill>
                 <a:latin typeface="Consolas"/>
               </a:rPr>
-              <a:t>_OPERADOR_COMPOSTO = {</a:t>
+              <a:t>&lt;=   menor ou igual</a:t>
             </a:r>
           </a:p>
           <a:p>
@@ -7261,13 +7109,13 @@
               </a:spcAft>
             </a:pPr>
             <a:r>
-              <a:rPr sz="1400" b="0" i="0">
+              <a:rPr sz="2000" b="0" i="0">
                 <a:solidFill>
                   <a:srgbClr val="222222"/>
                 </a:solidFill>
                 <a:latin typeface="Consolas"/>
               </a:rPr>
-              <a:t>    "&lt;": (MENOR, MENOR_IGUAL),</a:t>
+              <a:t>&gt;=   maior ou igual</a:t>
             </a:r>
           </a:p>
           <a:p>
@@ -7280,89 +7128,13 @@
               </a:spcAft>
             </a:pPr>
             <a:r>
-              <a:rPr sz="1400" b="0" i="0">
+              <a:rPr sz="2000" b="0" i="0">
                 <a:solidFill>
                   <a:srgbClr val="222222"/>
                 </a:solidFill>
                 <a:latin typeface="Consolas"/>
               </a:rPr>
-              <a:t>    "&gt;": (MAIOR, MAIOR_IGUAL),</a:t>
-            </a:r>
-          </a:p>
-          <a:p>
-            <a:pPr algn="l">
-              <a:lnSpc>
-                <a:spcPct val="105000"/>
-              </a:lnSpc>
-              <a:spcAft>
-                <a:spcPts val="0"/>
-              </a:spcAft>
-            </a:pPr>
-            <a:r>
-              <a:rPr sz="1400" b="0" i="0">
-                <a:solidFill>
-                  <a:srgbClr val="222222"/>
-                </a:solidFill>
-                <a:latin typeface="Consolas"/>
-              </a:rPr>
-              <a:t>    ...</a:t>
-            </a:r>
-          </a:p>
-          <a:p>
-            <a:pPr algn="l">
-              <a:lnSpc>
-                <a:spcPct val="105000"/>
-              </a:lnSpc>
-              <a:spcAft>
-                <a:spcPts val="0"/>
-              </a:spcAft>
-            </a:pPr>
-            <a:r>
-              <a:rPr sz="1400" b="0" i="0">
-                <a:solidFill>
-                  <a:srgbClr val="222222"/>
-                </a:solidFill>
-                <a:latin typeface="Consolas"/>
-              </a:rPr>
-              <a:t>}</a:t>
-            </a:r>
-          </a:p>
-          <a:p>
-            <a:pPr algn="l">
-              <a:lnSpc>
-                <a:spcPct val="105000"/>
-              </a:lnSpc>
-              <a:spcAft>
-                <a:spcPts val="0"/>
-              </a:spcAft>
-            </a:pPr>
-            <a:r>
-              <a:rPr sz="1400" b="0" i="0">
-                <a:solidFill>
-                  <a:srgbClr val="222222"/>
-                </a:solidFill>
-                <a:latin typeface="Consolas"/>
-              </a:rPr>
-              <a:t># le o caractere seguinte sem</a:t>
-            </a:r>
-          </a:p>
-          <a:p>
-            <a:pPr algn="l">
-              <a:lnSpc>
-                <a:spcPct val="105000"/>
-              </a:lnSpc>
-              <a:spcAft>
-                <a:spcPts val="0"/>
-              </a:spcAft>
-            </a:pPr>
-            <a:r>
-              <a:rPr sz="1400" b="0" i="0">
-                <a:solidFill>
-                  <a:srgbClr val="222222"/>
-                </a:solidFill>
-                <a:latin typeface="Consolas"/>
-              </a:rPr>
-              <a:t># avancar ate decidir</a:t>
+              <a:t>!=   diferente</a:t>
             </a:r>
           </a:p>
         </p:txBody>
@@ -7375,8 +7147,8 @@
         </p:nvSpPr>
         <p:spPr>
           <a:xfrm>
-            <a:off x="7498079" y="2560320"/>
-            <a:ext cx="4206240" cy="365760"/>
+            <a:off x="7132320" y="2651760"/>
+            <a:ext cx="4572000" cy="365760"/>
           </a:xfrm>
           <a:prstGeom prst="rect">
             <a:avLst/>
@@ -7397,7 +7169,7 @@
                 </a:solidFill>
                 <a:latin typeface="Calibri"/>
               </a:rPr>
-              <a:t>Codegen: só mais um SETcc</a:t>
+              <a:t>Exemplo de uso</a:t>
             </a:r>
           </a:p>
         </p:txBody>
@@ -7410,8 +7182,8 @@
         </p:nvSpPr>
         <p:spPr>
           <a:xfrm>
-            <a:off x="7498079" y="2926080"/>
-            <a:ext cx="4206240" cy="2011680"/>
+            <a:off x="7132320" y="3017520"/>
+            <a:ext cx="4572000" cy="1828800"/>
           </a:xfrm>
           <a:prstGeom prst="rect">
             <a:avLst/>
@@ -7452,8 +7224,8 @@
         </p:nvSpPr>
         <p:spPr>
           <a:xfrm>
-            <a:off x="7662671" y="3090672"/>
-            <a:ext cx="3877056" cy="1682496"/>
+            <a:off x="7296912" y="3182112"/>
+            <a:ext cx="4242816" cy="1499616"/>
           </a:xfrm>
           <a:prstGeom prst="rect">
             <a:avLst/>
@@ -7475,13 +7247,13 @@
               </a:spcAft>
             </a:pPr>
             <a:r>
-              <a:rPr sz="1500" b="0" i="0">
+              <a:rPr sz="1600" b="0" i="0">
                 <a:solidFill>
                   <a:srgbClr val="222222"/>
                 </a:solidFill>
                 <a:latin typeface="Consolas"/>
               </a:rPr>
-              <a:t>&lt;=  →  setle %cl</a:t>
+              <a:t>if idade &gt;= 60 {</a:t>
             </a:r>
           </a:p>
           <a:p>
@@ -7494,13 +7266,13 @@
               </a:spcAft>
             </a:pPr>
             <a:r>
-              <a:rPr sz="1500" b="0" i="0">
+              <a:rPr sz="1600" b="0" i="0">
                 <a:solidFill>
                   <a:srgbClr val="222222"/>
                 </a:solidFill>
                 <a:latin typeface="Consolas"/>
               </a:rPr>
-              <a:t>&gt;=  →  setge %cl</a:t>
+              <a:t>  return 2;</a:t>
             </a:r>
           </a:p>
           <a:p>
@@ -7513,13 +7285,13 @@
               </a:spcAft>
             </a:pPr>
             <a:r>
-              <a:rPr sz="1500" b="0" i="0">
+              <a:rPr sz="1600" b="0" i="0">
                 <a:solidFill>
                   <a:srgbClr val="222222"/>
                 </a:solidFill>
                 <a:latin typeface="Consolas"/>
               </a:rPr>
-              <a:t>!=  →  setne %cl</a:t>
+              <a:t>}</a:t>
             </a:r>
           </a:p>
         </p:txBody>
@@ -7559,7 +7331,7 @@
               <a:rPr sz="1500" b="0" i="0">
                 <a:latin typeface="Calibri"/>
               </a:rPr>
-              <a:t>'!' sozinho não existe em Fun (sem operador de negação) — vira erro léxico.</a:t>
+              <a:t>Por dentro, foi tranquilo: reaproveitamos quase todo o código que já traduzia as comparações antigas.</a:t>
             </a:r>
           </a:p>
         </p:txBody>
@@ -7759,7 +7531,7 @@
                 </a:solidFill>
                 <a:latin typeface="Calibri"/>
               </a:rPr>
-              <a:t>Atribuição composta</a:t>
+              <a:t>Um atalho pra atualizar variáveis</a:t>
             </a:r>
           </a:p>
         </p:txBody>
@@ -7773,7 +7545,7 @@
         <p:spPr>
           <a:xfrm>
             <a:off x="548640" y="1828800"/>
-            <a:ext cx="11094415" cy="548640"/>
+            <a:ext cx="11094415" cy="640080"/>
           </a:xfrm>
           <a:prstGeom prst="rect">
             <a:avLst/>
@@ -7795,10 +7567,10 @@
               </a:spcAft>
             </a:pPr>
             <a:r>
-              <a:rPr sz="1700" b="0" i="0">
-                <a:latin typeface="Calibri"/>
-              </a:rPr>
-              <a:t>+=, -=, *=, /= — desmontados no PARSER, sem nó de AST novo.</a:t>
+              <a:rPr sz="1800" b="0" i="0">
+                <a:latin typeface="Calibri"/>
+              </a:rPr>
+              <a:t>Em vez de repetir o nome da variável duas vezes, agora dá pra escrever direto:</a:t>
             </a:r>
           </a:p>
         </p:txBody>
@@ -7811,8 +7583,8 @@
         </p:nvSpPr>
         <p:spPr>
           <a:xfrm>
-            <a:off x="548640" y="2560320"/>
-            <a:ext cx="11094415" cy="2011680"/>
+            <a:off x="548640" y="2651760"/>
+            <a:ext cx="11094415" cy="1645920"/>
           </a:xfrm>
           <a:prstGeom prst="rect">
             <a:avLst/>
@@ -7853,8 +7625,8 @@
         </p:nvSpPr>
         <p:spPr>
           <a:xfrm>
-            <a:off x="713232" y="2724912"/>
-            <a:ext cx="10765231" cy="1682496"/>
+            <a:off x="713232" y="2816352"/>
+            <a:ext cx="10765231" cy="1316736"/>
           </a:xfrm>
           <a:prstGeom prst="rect">
             <a:avLst/>
@@ -7876,51 +7648,13 @@
               </a:spcAft>
             </a:pPr>
             <a:r>
-              <a:rPr sz="1600" b="0" i="0">
+              <a:rPr sz="1700" b="0" i="0">
                 <a:solidFill>
                   <a:srgbClr val="222222"/>
                 </a:solidFill>
                 <a:latin typeface="Consolas"/>
               </a:rPr>
-              <a:t>x += 5;              vira exatamente       x = x + 5;</a:t>
-            </a:r>
-          </a:p>
-          <a:p>
-            <a:pPr algn="l">
-              <a:lnSpc>
-                <a:spcPct val="105000"/>
-              </a:lnSpc>
-              <a:spcAft>
-                <a:spcPts val="0"/>
-              </a:spcAft>
-            </a:pPr>
-            <a:r>
-              <a:rPr sz="1600" b="0" i="0">
-                <a:solidFill>
-                  <a:srgbClr val="222222"/>
-                </a:solidFill>
-                <a:latin typeface="Consolas"/>
-              </a:rPr>
-              <a:t> </a:t>
-            </a:r>
-          </a:p>
-          <a:p>
-            <a:pPr algn="l">
-              <a:lnSpc>
-                <a:spcPct val="105000"/>
-              </a:lnSpc>
-              <a:spcAft>
-                <a:spcPts val="0"/>
-              </a:spcAft>
-            </a:pPr>
-            <a:r>
-              <a:rPr sz="1600" b="0" i="0">
-                <a:solidFill>
-                  <a:srgbClr val="222222"/>
-                </a:solidFill>
-                <a:latin typeface="Consolas"/>
-              </a:rPr>
-              <a:t>Atrib(x, OpBin(SOMA, Var(x), Const(5)))</a:t>
+              <a:t>total += 5;      é a mesma coisa que      total = total + 5;</a:t>
             </a:r>
           </a:p>
         </p:txBody>
@@ -7933,8 +7667,8 @@
         </p:nvSpPr>
         <p:spPr>
           <a:xfrm>
-            <a:off x="548640" y="4937760"/>
-            <a:ext cx="11094415" cy="1463040"/>
+            <a:off x="548640" y="4663440"/>
+            <a:ext cx="11094415" cy="1737360"/>
           </a:xfrm>
           <a:prstGeom prst="rect">
             <a:avLst/>
@@ -7957,10 +7691,10 @@
               <a:buChar char="•"/>
             </a:pPr>
             <a:r>
-              <a:rPr sz="1600" b="0" i="0">
-                <a:latin typeface="Calibri"/>
-              </a:rPr>
-              <a:t>Semântica e codegen não mudam nada — processam o Atrib resultante como sempre processaram.</a:t>
+              <a:rPr sz="1700" b="0" i="0">
+                <a:latin typeface="Calibri"/>
+              </a:rPr>
+              <a:t>Funciona também com -=, *= e /=.</a:t>
             </a:r>
           </a:p>
           <a:p>
@@ -7974,13 +7708,10 @@
               <a:buChar char="•"/>
             </a:pPr>
             <a:r>
-              <a:rPr sz="1600" b="0" i="0">
-                <a:solidFill>
-                  <a:srgbClr val="2E8B57"/>
-                </a:solidFill>
-                <a:latin typeface="Calibri"/>
-              </a:rPr>
-              <a:t>Teste garante: assembly de x += 5; é byte a byte idêntico ao de x = x + 5;</a:t>
+              <a:rPr sz="1700" b="0" i="0">
+                <a:latin typeface="Calibri"/>
+              </a:rPr>
+              <a:t>Deixa o código bem mais limpo, principalmente dentro de laços.</a:t>
             </a:r>
           </a:p>
         </p:txBody>
@@ -8180,7 +7911,7 @@
                 </a:solidFill>
                 <a:latin typeface="Calibri"/>
               </a:rPr>
-              <a:t>Por que açúcar sintático?</a:t>
+              <a:t>Um detalhe legal dessa implementação</a:t>
             </a:r>
           </a:p>
         </p:txBody>
@@ -8193,8 +7924,8 @@
         </p:nvSpPr>
         <p:spPr>
           <a:xfrm>
-            <a:off x="548640" y="2011680"/>
-            <a:ext cx="11094415" cy="3200400"/>
+            <a:off x="548640" y="2194560"/>
+            <a:ext cx="11094415" cy="2743200"/>
           </a:xfrm>
           <a:prstGeom prst="rect">
             <a:avLst/>
@@ -8216,10 +7947,13 @@
               </a:spcAft>
             </a:pPr>
             <a:r>
-              <a:rPr sz="1700" b="0" i="0">
-                <a:latin typeface="Calibri"/>
-              </a:rPr>
-              <a:t>Alternativa considerada: um nó AtribComposta próprio, com sua própria verificação semântica e geração de código.</a:t>
+              <a:rPr sz="1900" b="1" i="0">
+                <a:solidFill>
+                  <a:srgbClr val="1F3A5F"/>
+                </a:solidFill>
+                <a:latin typeface="Calibri"/>
+              </a:rPr>
+              <a:t>A gente não criou nada novo por trás dos panos.</a:t>
             </a:r>
           </a:p>
           <a:p>
@@ -8248,10 +7982,10 @@
               </a:spcAft>
             </a:pPr>
             <a:r>
-              <a:rPr sz="1700" b="0" i="0">
-                <a:latin typeface="Calibri"/>
-              </a:rPr>
-              <a:t>Por que não: um Atrib já representa perfeitamente uma atribuição — a única diferença é como o valor é calculado, não que tipo de comando é.</a:t>
+              <a:rPr sz="1800" b="0" i="0">
+                <a:latin typeface="Calibri"/>
+              </a:rPr>
+              <a:t>O += simplesmente vira, na hora de compilar, a mesma coisa que escrever por extenso — zero código novo pra gerar o resultado.</a:t>
             </a:r>
           </a:p>
           <a:p>
@@ -8280,13 +8014,13 @@
               </a:spcAft>
             </a:pPr>
             <a:r>
-              <a:rPr sz="1700" b="1" i="0">
+              <a:rPr sz="1800" b="0" i="0">
                 <a:solidFill>
                   <a:srgbClr val="2E8B57"/>
                 </a:solidFill>
                 <a:latin typeface="Calibri"/>
               </a:rPr>
-              <a:t>Resultado: menos código, e a prova de corretude fica trivial (compara o assembly das duas formas).</a:t>
+              <a:t>E testamos justamente isso: as duas formas geram exatamente o mesmo resultado, sem diferença nenhuma.</a:t>
             </a:r>
           </a:p>
         </p:txBody>
@@ -8486,21 +8220,95 @@
                 </a:solidFill>
                 <a:latin typeface="Calibri"/>
               </a:rPr>
-              <a:t>return como comando: o problema</a:t>
-            </a:r>
-          </a:p>
-        </p:txBody>
-      </p:sp>
-      <p:sp>
-        <p:nvSpPr>
-          <p:cNvPr id="5" name="Rectangle 4"/>
+              <a:t>Saindo de uma função mais cedo</a:t>
+            </a:r>
+          </a:p>
+        </p:txBody>
+      </p:sp>
+      <p:sp>
+        <p:nvSpPr>
+          <p:cNvPr id="5" name="TextBox 4"/>
+          <p:cNvSpPr txBox="1"/>
+          <p:nvPr/>
+        </p:nvSpPr>
+        <p:spPr>
+          <a:xfrm>
+            <a:off x="548640" y="1828800"/>
+            <a:ext cx="11094415" cy="1280160"/>
+          </a:xfrm>
+          <a:prstGeom prst="rect">
+            <a:avLst/>
+          </a:prstGeom>
+          <a:noFill/>
+        </p:spPr>
+        <p:txBody>
+          <a:bodyPr wrap="square" lIns="0" rIns="0" tIns="0" bIns="0">
+            <a:spAutoFit/>
+          </a:bodyPr>
+          <a:lstStyle/>
+          <a:p>
+            <a:pPr algn="l">
+              <a:lnSpc>
+                <a:spcPct val="115000"/>
+              </a:lnSpc>
+              <a:spcAft>
+                <a:spcPts val="400"/>
+              </a:spcAft>
+            </a:pPr>
+            <a:r>
+              <a:rPr sz="1800" b="0" i="0">
+                <a:latin typeface="Calibri"/>
+              </a:rPr>
+              <a:t>Antes, uma função só podia terminar com return bem no finalzinho dela. Se quisesse sair mais cedo — de dentro de um if, por exemplo — não dava.</a:t>
+            </a:r>
+          </a:p>
+        </p:txBody>
+      </p:sp>
+      <p:sp>
+        <p:nvSpPr>
+          <p:cNvPr id="6" name="TextBox 5"/>
+          <p:cNvSpPr txBox="1"/>
+          <p:nvPr/>
+        </p:nvSpPr>
+        <p:spPr>
+          <a:xfrm>
+            <a:off x="548640" y="3017520"/>
+            <a:ext cx="5272887" cy="365760"/>
+          </a:xfrm>
+          <a:prstGeom prst="rect">
+            <a:avLst/>
+          </a:prstGeom>
+          <a:noFill/>
+        </p:spPr>
+        <p:txBody>
+          <a:bodyPr wrap="square" anchor="t" lIns="0" rIns="0" tIns="0" bIns="0">
+            <a:spAutoFit/>
+          </a:bodyPr>
+          <a:lstStyle/>
+          <a:p>
+            <a:pPr algn="l"/>
+            <a:r>
+              <a:rPr sz="1400" b="1" i="0">
+                <a:solidFill>
+                  <a:srgbClr val="666666"/>
+                </a:solidFill>
+                <a:latin typeface="Calibri"/>
+              </a:rPr>
+              <a:t>Antes: precisava de uma variável extra</a:t>
+            </a:r>
+          </a:p>
+        </p:txBody>
+      </p:sp>
+      <p:sp>
+        <p:nvSpPr>
+          <p:cNvPr id="7" name="Rectangle 6"/>
           <p:cNvSpPr/>
           <p:nvPr/>
         </p:nvSpPr>
         <p:spPr>
           <a:xfrm>
-            <a:off x="548640" y="1828800"/>
-            <a:ext cx="11094415" cy="1463040"/>
+            <a:off x="548640" y="3383280"/>
+            <a:ext cx="5272887" cy="2651760"/>
           </a:xfrm>
           <a:prstGeom prst="rect">
             <a:avLst/>
@@ -8535,14 +8343,14 @@
       </p:sp>
       <p:sp>
         <p:nvSpPr>
-          <p:cNvPr id="6" name="TextBox 5"/>
+          <p:cNvPr id="8" name="TextBox 7"/>
           <p:cNvSpPr txBox="1"/>
           <p:nvPr/>
         </p:nvSpPr>
         <p:spPr>
           <a:xfrm>
-            <a:off x="713232" y="1993392"/>
-            <a:ext cx="10765231" cy="1133856"/>
+            <a:off x="713232" y="3547872"/>
+            <a:ext cx="4943703" cy="2322576"/>
           </a:xfrm>
           <a:prstGeom prst="rect">
             <a:avLst/>
@@ -8564,13 +8372,13 @@
               </a:spcAft>
             </a:pPr>
             <a:r>
-              <a:rPr sz="1600" b="0" i="0">
+              <a:rPr sz="1300" b="0" i="0">
                 <a:solidFill>
                   <a:srgbClr val="222222"/>
                 </a:solidFill>
                 <a:latin typeface="Consolas"/>
               </a:rPr>
-              <a:t>&lt;corpo&gt; ::= &lt;cmd&gt;* 'return' &lt;exp&gt; ';' '}'</a:t>
+              <a:t>fun sinal(n) {</a:t>
             </a:r>
           </a:p>
           <a:p>
@@ -8583,27 +8391,237 @@
               </a:spcAft>
             </a:pPr>
             <a:r>
-              <a:rPr sz="1600" b="0" i="0">
+              <a:rPr sz="1300" b="0" i="0">
                 <a:solidFill>
                   <a:srgbClr val="222222"/>
                 </a:solidFill>
                 <a:latin typeface="Consolas"/>
               </a:rPr>
-              <a:t>                        ^^^^^^ obrigatorio, sempre por ultimo</a:t>
-            </a:r>
-          </a:p>
-        </p:txBody>
-      </p:sp>
-      <p:sp>
-        <p:nvSpPr>
-          <p:cNvPr id="7" name="TextBox 6"/>
+              <a:t>  var r = 0;</a:t>
+            </a:r>
+          </a:p>
+          <a:p>
+            <a:pPr algn="l">
+              <a:lnSpc>
+                <a:spcPct val="105000"/>
+              </a:lnSpc>
+              <a:spcAft>
+                <a:spcPts val="0"/>
+              </a:spcAft>
+            </a:pPr>
+            <a:r>
+              <a:rPr sz="1300" b="0" i="0">
+                <a:solidFill>
+                  <a:srgbClr val="222222"/>
+                </a:solidFill>
+                <a:latin typeface="Consolas"/>
+              </a:rPr>
+              <a:t>  if n &lt; 0 { r = 0-1; }</a:t>
+            </a:r>
+          </a:p>
+          <a:p>
+            <a:pPr algn="l">
+              <a:lnSpc>
+                <a:spcPct val="105000"/>
+              </a:lnSpc>
+              <a:spcAft>
+                <a:spcPts val="0"/>
+              </a:spcAft>
+            </a:pPr>
+            <a:r>
+              <a:rPr sz="1300" b="0" i="0">
+                <a:solidFill>
+                  <a:srgbClr val="222222"/>
+                </a:solidFill>
+                <a:latin typeface="Consolas"/>
+              </a:rPr>
+              <a:t>  else {</a:t>
+            </a:r>
+          </a:p>
+          <a:p>
+            <a:pPr algn="l">
+              <a:lnSpc>
+                <a:spcPct val="105000"/>
+              </a:lnSpc>
+              <a:spcAft>
+                <a:spcPts val="0"/>
+              </a:spcAft>
+            </a:pPr>
+            <a:r>
+              <a:rPr sz="1300" b="0" i="0">
+                <a:solidFill>
+                  <a:srgbClr val="222222"/>
+                </a:solidFill>
+                <a:latin typeface="Consolas"/>
+              </a:rPr>
+              <a:t>    if n == 0 { r = 0; }</a:t>
+            </a:r>
+          </a:p>
+          <a:p>
+            <a:pPr algn="l">
+              <a:lnSpc>
+                <a:spcPct val="105000"/>
+              </a:lnSpc>
+              <a:spcAft>
+                <a:spcPts val="0"/>
+              </a:spcAft>
+            </a:pPr>
+            <a:r>
+              <a:rPr sz="1300" b="0" i="0">
+                <a:solidFill>
+                  <a:srgbClr val="222222"/>
+                </a:solidFill>
+                <a:latin typeface="Consolas"/>
+              </a:rPr>
+              <a:t>    else { r = 1; }</a:t>
+            </a:r>
+          </a:p>
+          <a:p>
+            <a:pPr algn="l">
+              <a:lnSpc>
+                <a:spcPct val="105000"/>
+              </a:lnSpc>
+              <a:spcAft>
+                <a:spcPts val="0"/>
+              </a:spcAft>
+            </a:pPr>
+            <a:r>
+              <a:rPr sz="1300" b="0" i="0">
+                <a:solidFill>
+                  <a:srgbClr val="222222"/>
+                </a:solidFill>
+                <a:latin typeface="Consolas"/>
+              </a:rPr>
+              <a:t>  }</a:t>
+            </a:r>
+          </a:p>
+          <a:p>
+            <a:pPr algn="l">
+              <a:lnSpc>
+                <a:spcPct val="105000"/>
+              </a:lnSpc>
+              <a:spcAft>
+                <a:spcPts val="0"/>
+              </a:spcAft>
+            </a:pPr>
+            <a:r>
+              <a:rPr sz="1300" b="0" i="0">
+                <a:solidFill>
+                  <a:srgbClr val="222222"/>
+                </a:solidFill>
+                <a:latin typeface="Consolas"/>
+              </a:rPr>
+              <a:t>  return r;</a:t>
+            </a:r>
+          </a:p>
+          <a:p>
+            <a:pPr algn="l">
+              <a:lnSpc>
+                <a:spcPct val="105000"/>
+              </a:lnSpc>
+              <a:spcAft>
+                <a:spcPts val="0"/>
+              </a:spcAft>
+            </a:pPr>
+            <a:r>
+              <a:rPr sz="1300" b="0" i="0">
+                <a:solidFill>
+                  <a:srgbClr val="222222"/>
+                </a:solidFill>
+                <a:latin typeface="Consolas"/>
+              </a:rPr>
+              <a:t>}</a:t>
+            </a:r>
+          </a:p>
+        </p:txBody>
+      </p:sp>
+      <p:sp>
+        <p:nvSpPr>
+          <p:cNvPr id="9" name="TextBox 8"/>
           <p:cNvSpPr txBox="1"/>
           <p:nvPr/>
         </p:nvSpPr>
         <p:spPr>
           <a:xfrm>
-            <a:off x="548640" y="3657600"/>
-            <a:ext cx="11094415" cy="2560320"/>
+            <a:off x="6370167" y="3017520"/>
+            <a:ext cx="5272887" cy="365760"/>
+          </a:xfrm>
+          <a:prstGeom prst="rect">
+            <a:avLst/>
+          </a:prstGeom>
+          <a:noFill/>
+        </p:spPr>
+        <p:txBody>
+          <a:bodyPr wrap="square" anchor="t" lIns="0" rIns="0" tIns="0" bIns="0">
+            <a:spAutoFit/>
+          </a:bodyPr>
+          <a:lstStyle/>
+          <a:p>
+            <a:pPr algn="l"/>
+            <a:r>
+              <a:rPr sz="1400" b="1" i="0">
+                <a:solidFill>
+                  <a:srgbClr val="2E8B57"/>
+                </a:solidFill>
+                <a:latin typeface="Calibri"/>
+              </a:rPr>
+              <a:t>Agora: sai na hora</a:t>
+            </a:r>
+          </a:p>
+        </p:txBody>
+      </p:sp>
+      <p:sp>
+        <p:nvSpPr>
+          <p:cNvPr id="10" name="Rectangle 9"/>
+          <p:cNvSpPr/>
+          <p:nvPr/>
+        </p:nvSpPr>
+        <p:spPr>
+          <a:xfrm>
+            <a:off x="6370167" y="3383280"/>
+            <a:ext cx="5272887" cy="2651760"/>
+          </a:xfrm>
+          <a:prstGeom prst="rect">
+            <a:avLst/>
+          </a:prstGeom>
+          <a:solidFill>
+            <a:srgbClr val="F4F4F4"/>
+          </a:solidFill>
+          <a:ln>
+            <a:noFill/>
+          </a:ln>
+          <a:effectLst/>
+        </p:spPr>
+        <p:style>
+          <a:lnRef idx="1">
+            <a:schemeClr val="accent1"/>
+          </a:lnRef>
+          <a:fillRef idx="3">
+            <a:schemeClr val="accent1"/>
+          </a:fillRef>
+          <a:effectRef idx="2">
+            <a:schemeClr val="accent1"/>
+          </a:effectRef>
+          <a:fontRef idx="minor">
+            <a:schemeClr val="lt1"/>
+          </a:fontRef>
+        </p:style>
+        <p:txBody>
+          <a:bodyPr rtlCol="0" anchor="ctr"/>
+          <a:lstStyle/>
+          <a:p/>
+        </p:txBody>
+      </p:sp>
+      <p:sp>
+        <p:nvSpPr>
+          <p:cNvPr id="11" name="TextBox 10"/>
+          <p:cNvSpPr txBox="1"/>
+          <p:nvPr/>
+        </p:nvSpPr>
+        <p:spPr>
+          <a:xfrm>
+            <a:off x="6534759" y="3547872"/>
+            <a:ext cx="4943703" cy="2322576"/>
           </a:xfrm>
           <a:prstGeom prst="rect">
             <a:avLst/>
@@ -8618,59 +8636,179 @@
           <a:p>
             <a:pPr algn="l">
               <a:lnSpc>
-                <a:spcPct val="130000"/>
-              </a:lnSpc>
-              <a:spcAft>
-                <a:spcPts val="400"/>
-              </a:spcAft>
-            </a:pPr>
-            <a:r>
-              <a:rPr sz="1700" b="0" i="0">
-                <a:latin typeface="Calibri"/>
-              </a:rPr>
-              <a:t>Queremos permitir return também dentro de if/while, não só como última instrução.</a:t>
+                <a:spcPct val="105000"/>
+              </a:lnSpc>
+              <a:spcAft>
+                <a:spcPts val="0"/>
+              </a:spcAft>
+            </a:pPr>
+            <a:r>
+              <a:rPr sz="1300" b="0" i="0">
+                <a:solidFill>
+                  <a:srgbClr val="222222"/>
+                </a:solidFill>
+                <a:latin typeface="Consolas"/>
+              </a:rPr>
+              <a:t>fun sinal(n) {</a:t>
             </a:r>
           </a:p>
           <a:p>
             <a:pPr algn="l">
               <a:lnSpc>
-                <a:spcPct val="130000"/>
-              </a:lnSpc>
-              <a:spcAft>
-                <a:spcPts val="400"/>
-              </a:spcAft>
-            </a:pPr>
-            <a:r>
-              <a:rPr sz="1000" b="0" i="0">
-                <a:latin typeface="Calibri"/>
-              </a:rPr>
-              <a:t/>
+                <a:spcPct val="105000"/>
+              </a:lnSpc>
+              <a:spcAft>
+                <a:spcPts val="0"/>
+              </a:spcAft>
+            </a:pPr>
+            <a:r>
+              <a:rPr sz="1300" b="0" i="0">
+                <a:solidFill>
+                  <a:srgbClr val="222222"/>
+                </a:solidFill>
+                <a:latin typeface="Consolas"/>
+              </a:rPr>
+              <a:t>  if n &lt; 0 {</a:t>
             </a:r>
           </a:p>
           <a:p>
             <a:pPr algn="l">
               <a:lnSpc>
-                <a:spcPct val="130000"/>
-              </a:lnSpc>
-              <a:spcAft>
-                <a:spcPts val="400"/>
-              </a:spcAft>
-            </a:pPr>
-            <a:r>
-              <a:rPr sz="1700" b="0" i="1">
-                <a:solidFill>
-                  <a:srgbClr val="666666"/>
-                </a:solidFill>
-                <a:latin typeface="Calibri"/>
-              </a:rPr>
-              <a:t>Problema: se return pode aparecer em qualquer lugar, como o parser sabe qual é o obrigatório (o do fim) e qual é antecipado?</a:t>
-            </a:r>
-          </a:p>
-        </p:txBody>
-      </p:sp>
-      <p:sp>
-        <p:nvSpPr>
-          <p:cNvPr id="8" name="TextBox 7"/>
+                <a:spcPct val="105000"/>
+              </a:lnSpc>
+              <a:spcAft>
+                <a:spcPts val="0"/>
+              </a:spcAft>
+            </a:pPr>
+            <a:r>
+              <a:rPr sz="1300" b="0" i="0">
+                <a:solidFill>
+                  <a:srgbClr val="222222"/>
+                </a:solidFill>
+                <a:latin typeface="Consolas"/>
+              </a:rPr>
+              <a:t>    return 0-1;</a:t>
+            </a:r>
+          </a:p>
+          <a:p>
+            <a:pPr algn="l">
+              <a:lnSpc>
+                <a:spcPct val="105000"/>
+              </a:lnSpc>
+              <a:spcAft>
+                <a:spcPts val="0"/>
+              </a:spcAft>
+            </a:pPr>
+            <a:r>
+              <a:rPr sz="1300" b="0" i="0">
+                <a:solidFill>
+                  <a:srgbClr val="222222"/>
+                </a:solidFill>
+                <a:latin typeface="Consolas"/>
+              </a:rPr>
+              <a:t>  } else {}</a:t>
+            </a:r>
+          </a:p>
+          <a:p>
+            <a:pPr algn="l">
+              <a:lnSpc>
+                <a:spcPct val="105000"/>
+              </a:lnSpc>
+              <a:spcAft>
+                <a:spcPts val="0"/>
+              </a:spcAft>
+            </a:pPr>
+            <a:r>
+              <a:rPr sz="1300" b="0" i="0">
+                <a:solidFill>
+                  <a:srgbClr val="222222"/>
+                </a:solidFill>
+                <a:latin typeface="Consolas"/>
+              </a:rPr>
+              <a:t>  if n == 0 {</a:t>
+            </a:r>
+          </a:p>
+          <a:p>
+            <a:pPr algn="l">
+              <a:lnSpc>
+                <a:spcPct val="105000"/>
+              </a:lnSpc>
+              <a:spcAft>
+                <a:spcPts val="0"/>
+              </a:spcAft>
+            </a:pPr>
+            <a:r>
+              <a:rPr sz="1300" b="0" i="0">
+                <a:solidFill>
+                  <a:srgbClr val="222222"/>
+                </a:solidFill>
+                <a:latin typeface="Consolas"/>
+              </a:rPr>
+              <a:t>    return 0;</a:t>
+            </a:r>
+          </a:p>
+          <a:p>
+            <a:pPr algn="l">
+              <a:lnSpc>
+                <a:spcPct val="105000"/>
+              </a:lnSpc>
+              <a:spcAft>
+                <a:spcPts val="0"/>
+              </a:spcAft>
+            </a:pPr>
+            <a:r>
+              <a:rPr sz="1300" b="0" i="0">
+                <a:solidFill>
+                  <a:srgbClr val="222222"/>
+                </a:solidFill>
+                <a:latin typeface="Consolas"/>
+              </a:rPr>
+              <a:t>  } else {}</a:t>
+            </a:r>
+          </a:p>
+          <a:p>
+            <a:pPr algn="l">
+              <a:lnSpc>
+                <a:spcPct val="105000"/>
+              </a:lnSpc>
+              <a:spcAft>
+                <a:spcPts val="0"/>
+              </a:spcAft>
+            </a:pPr>
+            <a:r>
+              <a:rPr sz="1300" b="0" i="0">
+                <a:solidFill>
+                  <a:srgbClr val="222222"/>
+                </a:solidFill>
+                <a:latin typeface="Consolas"/>
+              </a:rPr>
+              <a:t>  return 1;</a:t>
+            </a:r>
+          </a:p>
+          <a:p>
+            <a:pPr algn="l">
+              <a:lnSpc>
+                <a:spcPct val="105000"/>
+              </a:lnSpc>
+              <a:spcAft>
+                <a:spcPts val="0"/>
+              </a:spcAft>
+            </a:pPr>
+            <a:r>
+              <a:rPr sz="1300" b="0" i="0">
+                <a:solidFill>
+                  <a:srgbClr val="222222"/>
+                </a:solidFill>
+                <a:latin typeface="Consolas"/>
+              </a:rPr>
+              <a:t>}</a:t>
+            </a:r>
+          </a:p>
+        </p:txBody>
+      </p:sp>
+      <p:sp>
+        <p:nvSpPr>
+          <p:cNvPr id="12" name="TextBox 11"/>
           <p:cNvSpPr txBox="1"/>
           <p:nvPr/>
         </p:nvSpPr>
@@ -8705,7 +8843,7 @@
       </p:sp>
       <p:sp>
         <p:nvSpPr>
-          <p:cNvPr id="9" name="TextBox 8"/>
+          <p:cNvPr id="13" name="TextBox 12"/>
           <p:cNvSpPr txBox="1"/>
           <p:nvPr/>
         </p:nvSpPr>
@@ -8863,21 +9001,60 @@
                 </a:solidFill>
                 <a:latin typeface="Calibri"/>
               </a:rPr>
-              <a:t>A solução: peek de 1 token</a:t>
-            </a:r>
-          </a:p>
-        </p:txBody>
-      </p:sp>
-      <p:sp>
-        <p:nvSpPr>
-          <p:cNvPr id="5" name="Rectangle 4"/>
+              <a:t>O desafio de fazer isso funcionar</a:t>
+            </a:r>
+          </a:p>
+        </p:txBody>
+      </p:sp>
+      <p:sp>
+        <p:nvSpPr>
+          <p:cNvPr id="5" name="TextBox 4"/>
+          <p:cNvSpPr txBox="1"/>
+          <p:nvPr/>
+        </p:nvSpPr>
+        <p:spPr>
+          <a:xfrm>
+            <a:off x="548640" y="1828800"/>
+            <a:ext cx="11094415" cy="1463040"/>
+          </a:xfrm>
+          <a:prstGeom prst="rect">
+            <a:avLst/>
+          </a:prstGeom>
+          <a:noFill/>
+        </p:spPr>
+        <p:txBody>
+          <a:bodyPr wrap="square" lIns="0" rIns="0" tIns="0" bIns="0">
+            <a:spAutoFit/>
+          </a:bodyPr>
+          <a:lstStyle/>
+          <a:p>
+            <a:pPr algn="l">
+              <a:lnSpc>
+                <a:spcPct val="115000"/>
+              </a:lnSpc>
+              <a:spcAft>
+                <a:spcPts val="400"/>
+              </a:spcAft>
+            </a:pPr>
+            <a:r>
+              <a:rPr sz="1800" b="0" i="0">
+                <a:latin typeface="Calibri"/>
+              </a:rPr>
+              <a:t>O compilador só conhecia um tipo de return: o do finalzinho. Agora ele precisa diferenciar: esse return aqui é o que encerra tudo, ou é um dos que aparecem no meio do caminho?</a:t>
+            </a:r>
+          </a:p>
+        </p:txBody>
+      </p:sp>
+      <p:sp>
+        <p:nvSpPr>
+          <p:cNvPr id="6" name="Rectangle 5"/>
           <p:cNvSpPr/>
           <p:nvPr/>
         </p:nvSpPr>
         <p:spPr>
           <a:xfrm>
-            <a:off x="548640" y="1828800"/>
-            <a:ext cx="6583680" cy="3108960"/>
+            <a:off x="548640" y="3291840"/>
+            <a:ext cx="11094415" cy="2743200"/>
           </a:xfrm>
           <a:prstGeom prst="rect">
             <a:avLst/>
@@ -8912,14 +9089,14 @@
       </p:sp>
       <p:sp>
         <p:nvSpPr>
-          <p:cNvPr id="6" name="TextBox 5"/>
+          <p:cNvPr id="7" name="TextBox 6"/>
           <p:cNvSpPr txBox="1"/>
           <p:nvPr/>
         </p:nvSpPr>
         <p:spPr>
           <a:xfrm>
-            <a:off x="713232" y="1993392"/>
-            <a:ext cx="6254496" cy="2779776"/>
+            <a:off x="713232" y="3456432"/>
+            <a:ext cx="10765231" cy="2414016"/>
           </a:xfrm>
           <a:prstGeom prst="rect">
             <a:avLst/>
@@ -8941,13 +9118,13 @@
               </a:spcAft>
             </a:pPr>
             <a:r>
-              <a:rPr sz="1400" b="0" i="0">
+              <a:rPr sz="1300" b="0" i="0">
                 <a:solidFill>
                   <a:srgbClr val="222222"/>
                 </a:solidFill>
                 <a:latin typeface="Consolas"/>
               </a:rPr>
-              <a:t>ao encontrar 'return':</a:t>
+              <a:t>fun sinal(n) {</a:t>
             </a:r>
           </a:p>
           <a:p>
@@ -8960,13 +9137,13 @@
               </a:spcAft>
             </a:pPr>
             <a:r>
-              <a:rPr sz="1400" b="0" i="0">
+              <a:rPr sz="1300" b="0" i="0">
                 <a:solidFill>
                   <a:srgbClr val="222222"/>
                 </a:solidFill>
                 <a:latin typeface="Consolas"/>
               </a:rPr>
-              <a:t>  consome 'return' &lt;exp&gt; ';'</a:t>
+              <a:t>  if n &lt; 0 { return 0-1; } else {}   &lt;- antecipado, tem mais coisa depois</a:t>
             </a:r>
           </a:p>
           <a:p>
@@ -8979,13 +9156,13 @@
               </a:spcAft>
             </a:pPr>
             <a:r>
-              <a:rPr sz="1400" b="0" i="0">
+              <a:rPr sz="1300" b="0" i="0">
                 <a:solidFill>
                   <a:srgbClr val="222222"/>
                 </a:solidFill>
                 <a:latin typeface="Consolas"/>
               </a:rPr>
-              <a:t>  olha o token seguinte</a:t>
+              <a:t>  if n == 0 { return 0; } else {}    &lt;- antecipado, tem mais coisa depois</a:t>
             </a:r>
           </a:p>
           <a:p>
@@ -8998,13 +9175,13 @@
               </a:spcAft>
             </a:pPr>
             <a:r>
-              <a:rPr sz="1400" b="0" i="0">
+              <a:rPr sz="1300" b="0" i="0">
                 <a:solidFill>
                   <a:srgbClr val="222222"/>
                 </a:solidFill>
                 <a:latin typeface="Consolas"/>
               </a:rPr>
-              <a:t>  se for '}':</a:t>
+              <a:t>  return 1;                          &lt;- esse sim e o ultimo de verdade</a:t>
             </a:r>
           </a:p>
           <a:p>
@@ -9017,84 +9194,70 @@
               </a:spcAft>
             </a:pPr>
             <a:r>
-              <a:rPr sz="1400" b="0" i="0">
+              <a:rPr sz="1300" b="0" i="0">
                 <a:solidFill>
                   <a:srgbClr val="222222"/>
                 </a:solidFill>
                 <a:latin typeface="Consolas"/>
               </a:rPr>
-              <a:t>    e o return FINAL -&gt; vira exp_final</a:t>
-            </a:r>
-          </a:p>
-          <a:p>
-            <a:pPr algn="l">
-              <a:lnSpc>
-                <a:spcPct val="105000"/>
-              </a:lnSpc>
-              <a:spcAft>
-                <a:spcPts val="0"/>
-              </a:spcAft>
-            </a:pPr>
-            <a:r>
-              <a:rPr sz="1400" b="0" i="0">
-                <a:solidFill>
-                  <a:srgbClr val="222222"/>
-                </a:solidFill>
-                <a:latin typeface="Consolas"/>
-              </a:rPr>
-              <a:t>  senao:</a:t>
-            </a:r>
-          </a:p>
-          <a:p>
-            <a:pPr algn="l">
-              <a:lnSpc>
-                <a:spcPct val="105000"/>
-              </a:lnSpc>
-              <a:spcAft>
-                <a:spcPts val="0"/>
-              </a:spcAft>
-            </a:pPr>
-            <a:r>
-              <a:rPr sz="1400" b="0" i="0">
-                <a:solidFill>
-                  <a:srgbClr val="222222"/>
-                </a:solidFill>
-                <a:latin typeface="Consolas"/>
-              </a:rPr>
-              <a:t>    e um return ANTECIPADO -&gt; vira Cmd Return</a:t>
-            </a:r>
-          </a:p>
-          <a:p>
-            <a:pPr algn="l">
-              <a:lnSpc>
-                <a:spcPct val="105000"/>
-              </a:lnSpc>
-              <a:spcAft>
-                <a:spcPts val="0"/>
-              </a:spcAft>
-            </a:pPr>
-            <a:r>
-              <a:rPr sz="1400" b="0" i="0">
-                <a:solidFill>
-                  <a:srgbClr val="222222"/>
-                </a:solidFill>
-                <a:latin typeface="Consolas"/>
-              </a:rPr>
-              <a:t>    continua reconhecendo comandos</a:t>
-            </a:r>
-          </a:p>
-        </p:txBody>
-      </p:sp>
-      <p:sp>
-        <p:nvSpPr>
-          <p:cNvPr id="7" name="TextBox 6"/>
+              <a:t>}</a:t>
+            </a:r>
+          </a:p>
+        </p:txBody>
+      </p:sp>
+      <p:sp>
+        <p:nvSpPr>
+          <p:cNvPr id="8" name="TextBox 7"/>
           <p:cNvSpPr txBox="1"/>
           <p:nvPr/>
         </p:nvSpPr>
         <p:spPr>
           <a:xfrm>
-            <a:off x="7680960" y="1828800"/>
-            <a:ext cx="4023360" cy="365760"/>
+            <a:off x="548640" y="6126480"/>
+            <a:ext cx="11094415" cy="548640"/>
+          </a:xfrm>
+          <a:prstGeom prst="rect">
+            <a:avLst/>
+          </a:prstGeom>
+          <a:noFill/>
+        </p:spPr>
+        <p:txBody>
+          <a:bodyPr wrap="square" lIns="0" rIns="0" tIns="0" bIns="0">
+            <a:spAutoFit/>
+          </a:bodyPr>
+          <a:lstStyle/>
+          <a:p>
+            <a:pPr algn="l" indent="-228600" marL="228600" lvl="0">
+              <a:lnSpc>
+                <a:spcPct val="115000"/>
+              </a:lnSpc>
+              <a:spcAft>
+                <a:spcPts val="400"/>
+              </a:spcAft>
+              <a:buChar char="•"/>
+            </a:pPr>
+            <a:r>
+              <a:rPr sz="1500" b="0" i="0">
+                <a:solidFill>
+                  <a:srgbClr val="2E8B57"/>
+                </a:solidFill>
+                <a:latin typeface="Calibri"/>
+              </a:rPr>
+              <a:t>A solução: o compilador olha o que vem logo depois de cada return pra decidir qual é qual.</a:t>
+            </a:r>
+          </a:p>
+        </p:txBody>
+      </p:sp>
+      <p:sp>
+        <p:nvSpPr>
+          <p:cNvPr id="9" name="TextBox 8"/>
+          <p:cNvSpPr txBox="1"/>
+          <p:nvPr/>
+        </p:nvSpPr>
+        <p:spPr>
+          <a:xfrm>
+            <a:off x="11414455" y="6492240"/>
+            <a:ext cx="548640" cy="274320"/>
           </a:xfrm>
           <a:prstGeom prst="rect">
             <a:avLst/>
@@ -9107,251 +9270,15 @@
           </a:bodyPr>
           <a:lstStyle/>
           <a:p>
-            <a:pPr algn="l"/>
-            <a:r>
-              <a:rPr sz="1500" b="1" i="0">
-                <a:solidFill>
-                  <a:srgbClr val="2E75B6"/>
-                </a:solidFill>
-                <a:latin typeface="Calibri"/>
-              </a:rPr>
-              <a:t>sinal(n) usando return</a:t>
-            </a:r>
-          </a:p>
-        </p:txBody>
-      </p:sp>
-      <p:sp>
-        <p:nvSpPr>
-          <p:cNvPr id="8" name="Rectangle 7"/>
-          <p:cNvSpPr/>
-          <p:nvPr/>
-        </p:nvSpPr>
-        <p:spPr>
-          <a:xfrm>
-            <a:off x="7680960" y="2194560"/>
-            <a:ext cx="4023360" cy="2743200"/>
-          </a:xfrm>
-          <a:prstGeom prst="rect">
-            <a:avLst/>
-          </a:prstGeom>
-          <a:solidFill>
-            <a:srgbClr val="F4F4F4"/>
-          </a:solidFill>
-          <a:ln>
-            <a:noFill/>
-          </a:ln>
-          <a:effectLst/>
-        </p:spPr>
-        <p:style>
-          <a:lnRef idx="1">
-            <a:schemeClr val="accent1"/>
-          </a:lnRef>
-          <a:fillRef idx="3">
-            <a:schemeClr val="accent1"/>
-          </a:fillRef>
-          <a:effectRef idx="2">
-            <a:schemeClr val="accent1"/>
-          </a:effectRef>
-          <a:fontRef idx="minor">
-            <a:schemeClr val="lt1"/>
-          </a:fontRef>
-        </p:style>
-        <p:txBody>
-          <a:bodyPr rtlCol="0" anchor="ctr"/>
-          <a:lstStyle/>
-          <a:p/>
-        </p:txBody>
-      </p:sp>
-      <p:sp>
-        <p:nvSpPr>
-          <p:cNvPr id="9" name="TextBox 8"/>
-          <p:cNvSpPr txBox="1"/>
-          <p:nvPr/>
-        </p:nvSpPr>
-        <p:spPr>
-          <a:xfrm>
-            <a:off x="7845552" y="2359152"/>
-            <a:ext cx="3694176" cy="2414016"/>
-          </a:xfrm>
-          <a:prstGeom prst="rect">
-            <a:avLst/>
-          </a:prstGeom>
-          <a:noFill/>
-        </p:spPr>
-        <p:txBody>
-          <a:bodyPr wrap="square" lIns="0" rIns="0" tIns="0" bIns="0">
-            <a:spAutoFit/>
-          </a:bodyPr>
-          <a:lstStyle/>
-          <a:p>
-            <a:pPr algn="l">
-              <a:lnSpc>
-                <a:spcPct val="105000"/>
-              </a:lnSpc>
-              <a:spcAft>
-                <a:spcPts val="0"/>
-              </a:spcAft>
-            </a:pPr>
-            <a:r>
-              <a:rPr sz="1300" b="0" i="0">
-                <a:solidFill>
-                  <a:srgbClr val="222222"/>
-                </a:solidFill>
-                <a:latin typeface="Consolas"/>
-              </a:rPr>
-              <a:t>fun sinal(n) {</a:t>
-            </a:r>
-          </a:p>
-          <a:p>
-            <a:pPr algn="l">
-              <a:lnSpc>
-                <a:spcPct val="105000"/>
-              </a:lnSpc>
-              <a:spcAft>
-                <a:spcPts val="0"/>
-              </a:spcAft>
-            </a:pPr>
-            <a:r>
-              <a:rPr sz="1300" b="0" i="0">
-                <a:solidFill>
-                  <a:srgbClr val="222222"/>
-                </a:solidFill>
-                <a:latin typeface="Consolas"/>
-              </a:rPr>
-              <a:t>  if n &lt; 0 {</a:t>
-            </a:r>
-          </a:p>
-          <a:p>
-            <a:pPr algn="l">
-              <a:lnSpc>
-                <a:spcPct val="105000"/>
-              </a:lnSpc>
-              <a:spcAft>
-                <a:spcPts val="0"/>
-              </a:spcAft>
-            </a:pPr>
-            <a:r>
-              <a:rPr sz="1300" b="0" i="0">
-                <a:solidFill>
-                  <a:srgbClr val="222222"/>
-                </a:solidFill>
-                <a:latin typeface="Consolas"/>
-              </a:rPr>
-              <a:t>    return 0-1;</a:t>
-            </a:r>
-          </a:p>
-          <a:p>
-            <a:pPr algn="l">
-              <a:lnSpc>
-                <a:spcPct val="105000"/>
-              </a:lnSpc>
-              <a:spcAft>
-                <a:spcPts val="0"/>
-              </a:spcAft>
-            </a:pPr>
-            <a:r>
-              <a:rPr sz="1300" b="0" i="0">
-                <a:solidFill>
-                  <a:srgbClr val="222222"/>
-                </a:solidFill>
-                <a:latin typeface="Consolas"/>
-              </a:rPr>
-              <a:t>  } else {}</a:t>
-            </a:r>
-          </a:p>
-          <a:p>
-            <a:pPr algn="l">
-              <a:lnSpc>
-                <a:spcPct val="105000"/>
-              </a:lnSpc>
-              <a:spcAft>
-                <a:spcPts val="0"/>
-              </a:spcAft>
-            </a:pPr>
-            <a:r>
-              <a:rPr sz="1300" b="0" i="0">
-                <a:solidFill>
-                  <a:srgbClr val="222222"/>
-                </a:solidFill>
-                <a:latin typeface="Consolas"/>
-              </a:rPr>
-              <a:t>  if n == 0 {</a:t>
-            </a:r>
-          </a:p>
-          <a:p>
-            <a:pPr algn="l">
-              <a:lnSpc>
-                <a:spcPct val="105000"/>
-              </a:lnSpc>
-              <a:spcAft>
-                <a:spcPts val="0"/>
-              </a:spcAft>
-            </a:pPr>
-            <a:r>
-              <a:rPr sz="1300" b="0" i="0">
-                <a:solidFill>
-                  <a:srgbClr val="222222"/>
-                </a:solidFill>
-                <a:latin typeface="Consolas"/>
-              </a:rPr>
-              <a:t>    return 0;</a:t>
-            </a:r>
-          </a:p>
-          <a:p>
-            <a:pPr algn="l">
-              <a:lnSpc>
-                <a:spcPct val="105000"/>
-              </a:lnSpc>
-              <a:spcAft>
-                <a:spcPts val="0"/>
-              </a:spcAft>
-            </a:pPr>
-            <a:r>
-              <a:rPr sz="1300" b="0" i="0">
-                <a:solidFill>
-                  <a:srgbClr val="222222"/>
-                </a:solidFill>
-                <a:latin typeface="Consolas"/>
-              </a:rPr>
-              <a:t>  } else {}</a:t>
-            </a:r>
-          </a:p>
-          <a:p>
-            <a:pPr algn="l">
-              <a:lnSpc>
-                <a:spcPct val="105000"/>
-              </a:lnSpc>
-              <a:spcAft>
-                <a:spcPts val="0"/>
-              </a:spcAft>
-            </a:pPr>
-            <a:r>
-              <a:rPr sz="1300" b="0" i="0">
-                <a:solidFill>
-                  <a:srgbClr val="222222"/>
-                </a:solidFill>
-                <a:latin typeface="Consolas"/>
-              </a:rPr>
-              <a:t>  return 1;</a:t>
-            </a:r>
-          </a:p>
-          <a:p>
-            <a:pPr algn="l">
-              <a:lnSpc>
-                <a:spcPct val="105000"/>
-              </a:lnSpc>
-              <a:spcAft>
-                <a:spcPts val="0"/>
-              </a:spcAft>
-            </a:pPr>
-            <a:r>
-              <a:rPr sz="1300" b="0" i="0">
-                <a:solidFill>
-                  <a:srgbClr val="222222"/>
-                </a:solidFill>
-                <a:latin typeface="Consolas"/>
-              </a:rPr>
-              <a:t>}</a:t>
+            <a:pPr algn="r"/>
+            <a:r>
+              <a:rPr sz="1000" b="0" i="0">
+                <a:solidFill>
+                  <a:srgbClr val="666666"/>
+                </a:solidFill>
+                <a:latin typeface="Calibri"/>
+              </a:rPr>
+              <a:t>8/13</a:t>
             </a:r>
           </a:p>
         </p:txBody>
@@ -9359,81 +9286,6 @@
       <p:sp>
         <p:nvSpPr>
           <p:cNvPr id="10" name="TextBox 9"/>
-          <p:cNvSpPr txBox="1"/>
-          <p:nvPr/>
-        </p:nvSpPr>
-        <p:spPr>
-          <a:xfrm>
-            <a:off x="548640" y="5212080"/>
-            <a:ext cx="11094415" cy="1097280"/>
-          </a:xfrm>
-          <a:prstGeom prst="rect">
-            <a:avLst/>
-          </a:prstGeom>
-          <a:noFill/>
-        </p:spPr>
-        <p:txBody>
-          <a:bodyPr wrap="square" lIns="0" rIns="0" tIns="0" bIns="0">
-            <a:spAutoFit/>
-          </a:bodyPr>
-          <a:lstStyle/>
-          <a:p>
-            <a:pPr algn="l" indent="-228600" marL="228600" lvl="0">
-              <a:lnSpc>
-                <a:spcPct val="115000"/>
-              </a:lnSpc>
-              <a:spcAft>
-                <a:spcPts val="400"/>
-              </a:spcAft>
-              <a:buChar char="•"/>
-            </a:pPr>
-            <a:r>
-              <a:rPr sz="1500" b="0" i="0">
-                <a:latin typeface="Calibri"/>
-              </a:rPr>
-              <a:t>Dentro de if/while não há ambiguidade: lá, todo return é sempre antecipado.</a:t>
-            </a:r>
-          </a:p>
-        </p:txBody>
-      </p:sp>
-      <p:sp>
-        <p:nvSpPr>
-          <p:cNvPr id="11" name="TextBox 10"/>
-          <p:cNvSpPr txBox="1"/>
-          <p:nvPr/>
-        </p:nvSpPr>
-        <p:spPr>
-          <a:xfrm>
-            <a:off x="11414455" y="6492240"/>
-            <a:ext cx="548640" cy="274320"/>
-          </a:xfrm>
-          <a:prstGeom prst="rect">
-            <a:avLst/>
-          </a:prstGeom>
-          <a:noFill/>
-        </p:spPr>
-        <p:txBody>
-          <a:bodyPr wrap="square" anchor="t" lIns="0" rIns="0" tIns="0" bIns="0">
-            <a:spAutoFit/>
-          </a:bodyPr>
-          <a:lstStyle/>
-          <a:p>
-            <a:pPr algn="r"/>
-            <a:r>
-              <a:rPr sz="1000" b="0" i="0">
-                <a:solidFill>
-                  <a:srgbClr val="666666"/>
-                </a:solidFill>
-                <a:latin typeface="Calibri"/>
-              </a:rPr>
-              <a:t>8/13</a:t>
-            </a:r>
-          </a:p>
-        </p:txBody>
-      </p:sp>
-      <p:sp>
-        <p:nvSpPr>
-          <p:cNvPr id="12" name="TextBox 11"/>
           <p:cNvSpPr txBox="1"/>
           <p:nvPr/>
         </p:nvSpPr>
@@ -9591,21 +9443,60 @@
                 </a:solidFill>
                 <a:latin typeface="Calibri"/>
               </a:rPr>
-              <a:t>Geração de código do return antecipado</a:t>
-            </a:r>
-          </a:p>
-        </p:txBody>
-      </p:sp>
-      <p:sp>
-        <p:nvSpPr>
-          <p:cNvPr id="5" name="Rectangle 4"/>
+              <a:t>Como isso vira código de máquina</a:t>
+            </a:r>
+          </a:p>
+        </p:txBody>
+      </p:sp>
+      <p:sp>
+        <p:nvSpPr>
+          <p:cNvPr id="5" name="TextBox 4"/>
+          <p:cNvSpPr txBox="1"/>
+          <p:nvPr/>
+        </p:nvSpPr>
+        <p:spPr>
+          <a:xfrm>
+            <a:off x="548640" y="1828800"/>
+            <a:ext cx="11094415" cy="1097280"/>
+          </a:xfrm>
+          <a:prstGeom prst="rect">
+            <a:avLst/>
+          </a:prstGeom>
+          <a:noFill/>
+        </p:spPr>
+        <p:txBody>
+          <a:bodyPr wrap="square" lIns="0" rIns="0" tIns="0" bIns="0">
+            <a:spAutoFit/>
+          </a:bodyPr>
+          <a:lstStyle/>
+          <a:p>
+            <a:pPr algn="l">
+              <a:lnSpc>
+                <a:spcPct val="115000"/>
+              </a:lnSpc>
+              <a:spcAft>
+                <a:spcPts val="400"/>
+              </a:spcAft>
+            </a:pPr>
+            <a:r>
+              <a:rPr sz="1800" b="0" i="0">
+                <a:latin typeface="Calibri"/>
+              </a:rPr>
+              <a:t>Cada função ganhou um 'ponto de saída' fixo. Quando um return antecipado acontece, ele pula direto pra lá.</a:t>
+            </a:r>
+          </a:p>
+        </p:txBody>
+      </p:sp>
+      <p:sp>
+        <p:nvSpPr>
+          <p:cNvPr id="6" name="Rectangle 5"/>
           <p:cNvSpPr/>
           <p:nvPr/>
         </p:nvSpPr>
         <p:spPr>
           <a:xfrm>
-            <a:off x="548640" y="1828800"/>
-            <a:ext cx="11094415" cy="3291840"/>
+            <a:off x="548640" y="2926080"/>
+            <a:ext cx="11094415" cy="2377440"/>
           </a:xfrm>
           <a:prstGeom prst="rect">
             <a:avLst/>
@@ -9640,14 +9531,14 @@
       </p:sp>
       <p:sp>
         <p:nvSpPr>
-          <p:cNvPr id="6" name="TextBox 5"/>
+          <p:cNvPr id="7" name="TextBox 6"/>
           <p:cNvSpPr txBox="1"/>
           <p:nvPr/>
         </p:nvSpPr>
         <p:spPr>
           <a:xfrm>
-            <a:off x="713232" y="1993392"/>
-            <a:ext cx="10765231" cy="2962656"/>
+            <a:off x="713232" y="3090672"/>
+            <a:ext cx="10765231" cy="2048256"/>
           </a:xfrm>
           <a:prstGeom prst="rect">
             <a:avLst/>
@@ -9669,13 +9560,13 @@
               </a:spcAft>
             </a:pPr>
             <a:r>
-              <a:rPr sz="1500" b="0" i="0">
+              <a:rPr sz="1700" b="0" i="0">
                 <a:solidFill>
                   <a:srgbClr val="222222"/>
                 </a:solidFill>
                 <a:latin typeface="Consolas"/>
               </a:rPr>
-              <a:t>&lt;nome&gt;:</a:t>
+              <a:t>return 0 - 1;</a:t>
             </a:r>
           </a:p>
           <a:p>
@@ -9688,13 +9579,13 @@
               </a:spcAft>
             </a:pPr>
             <a:r>
-              <a:rPr sz="1500" b="0" i="0">
+              <a:rPr sz="1700" b="0" i="0">
                 <a:solidFill>
                   <a:srgbClr val="222222"/>
                 </a:solidFill>
                 <a:latin typeface="Consolas"/>
               </a:rPr>
-              <a:t>    push %rbp</a:t>
+              <a:t>    → calcula o valor</a:t>
             </a:r>
           </a:p>
           <a:p>
@@ -9707,141 +9598,27 @@
               </a:spcAft>
             </a:pPr>
             <a:r>
-              <a:rPr sz="1500" b="0" i="0">
+              <a:rPr sz="1700" b="0" i="0">
                 <a:solidFill>
                   <a:srgbClr val="222222"/>
                 </a:solidFill>
                 <a:latin typeface="Consolas"/>
               </a:rPr>
-              <a:t>    ...</a:t>
-            </a:r>
-          </a:p>
-          <a:p>
-            <a:pPr algn="l">
-              <a:lnSpc>
-                <a:spcPct val="105000"/>
-              </a:lnSpc>
-              <a:spcAft>
-                <a:spcPts val="0"/>
-              </a:spcAft>
-            </a:pPr>
-            <a:r>
-              <a:rPr sz="1500" b="0" i="0">
-                <a:solidFill>
-                  <a:srgbClr val="222222"/>
-                </a:solidFill>
-                <a:latin typeface="Consolas"/>
-              </a:rPr>
-              <a:t>    &lt;comandos, pode conter Return&gt;</a:t>
-            </a:r>
-          </a:p>
-          <a:p>
-            <a:pPr algn="l">
-              <a:lnSpc>
-                <a:spcPct val="105000"/>
-              </a:lnSpc>
-              <a:spcAft>
-                <a:spcPts val="0"/>
-              </a:spcAft>
-            </a:pPr>
-            <a:r>
-              <a:rPr sz="1500" b="0" i="0">
-                <a:solidFill>
-                  <a:srgbClr val="222222"/>
-                </a:solidFill>
-                <a:latin typeface="Consolas"/>
-              </a:rPr>
-              <a:t>    &lt;expressao final&gt;</a:t>
-            </a:r>
-          </a:p>
-          <a:p>
-            <a:pPr algn="l">
-              <a:lnSpc>
-                <a:spcPct val="105000"/>
-              </a:lnSpc>
-              <a:spcAft>
-                <a:spcPts val="0"/>
-              </a:spcAft>
-            </a:pPr>
-            <a:r>
-              <a:rPr sz="1500" b="0" i="0">
-                <a:solidFill>
-                  <a:srgbClr val="222222"/>
-                </a:solidFill>
-                <a:latin typeface="Consolas"/>
-              </a:rPr>
-              <a:t>Lfim_&lt;nome&gt;:              # rotulo de saida, SEMPRE emitido</a:t>
-            </a:r>
-          </a:p>
-          <a:p>
-            <a:pPr algn="l">
-              <a:lnSpc>
-                <a:spcPct val="105000"/>
-              </a:lnSpc>
-              <a:spcAft>
-                <a:spcPts val="0"/>
-              </a:spcAft>
-            </a:pPr>
-            <a:r>
-              <a:rPr sz="1500" b="0" i="0">
-                <a:solidFill>
-                  <a:srgbClr val="222222"/>
-                </a:solidFill>
-                <a:latin typeface="Consolas"/>
-              </a:rPr>
-              <a:t>    add $8*L, %rsp        # epilogo (igual Atividade 10)</a:t>
-            </a:r>
-          </a:p>
-          <a:p>
-            <a:pPr algn="l">
-              <a:lnSpc>
-                <a:spcPct val="105000"/>
-              </a:lnSpc>
-              <a:spcAft>
-                <a:spcPts val="0"/>
-              </a:spcAft>
-            </a:pPr>
-            <a:r>
-              <a:rPr sz="1500" b="0" i="0">
-                <a:solidFill>
-                  <a:srgbClr val="222222"/>
-                </a:solidFill>
-                <a:latin typeface="Consolas"/>
-              </a:rPr>
-              <a:t>    pop %rbp</a:t>
-            </a:r>
-          </a:p>
-          <a:p>
-            <a:pPr algn="l">
-              <a:lnSpc>
-                <a:spcPct val="105000"/>
-              </a:lnSpc>
-              <a:spcAft>
-                <a:spcPts val="0"/>
-              </a:spcAft>
-            </a:pPr>
-            <a:r>
-              <a:rPr sz="1500" b="0" i="0">
-                <a:solidFill>
-                  <a:srgbClr val="222222"/>
-                </a:solidFill>
-                <a:latin typeface="Consolas"/>
-              </a:rPr>
-              <a:t>    ret</a:t>
-            </a:r>
-          </a:p>
-        </p:txBody>
-      </p:sp>
-      <p:sp>
-        <p:nvSpPr>
-          <p:cNvPr id="7" name="TextBox 6"/>
+              <a:t>    → pula direto pro fim da função (ignora o resto)</a:t>
+            </a:r>
+          </a:p>
+        </p:txBody>
+      </p:sp>
+      <p:sp>
+        <p:nvSpPr>
+          <p:cNvPr id="8" name="TextBox 7"/>
           <p:cNvSpPr txBox="1"/>
           <p:nvPr/>
         </p:nvSpPr>
         <p:spPr>
           <a:xfrm>
-            <a:off x="548640" y="5394960"/>
-            <a:ext cx="11094415" cy="1097280"/>
+            <a:off x="548640" y="5486400"/>
+            <a:ext cx="11094415" cy="914400"/>
           </a:xfrm>
           <a:prstGeom prst="rect">
             <a:avLst/>
@@ -9864,17 +9641,20 @@
               <a:buChar char="•"/>
             </a:pPr>
             <a:r>
-              <a:rPr sz="1600" b="0" i="0">
-                <a:latin typeface="Calibri"/>
-              </a:rPr>
-              <a:t>Um Return so calcula a expressao (em %rax) e da jmp direto pra Lfim_&lt;nome&gt; — pula o resto do corpo.</a:t>
-            </a:r>
-          </a:p>
-        </p:txBody>
-      </p:sp>
-      <p:sp>
-        <p:nvSpPr>
-          <p:cNvPr id="8" name="TextBox 7"/>
+              <a:rPr sz="1600" b="0" i="1">
+                <a:solidFill>
+                  <a:srgbClr val="666666"/>
+                </a:solidFill>
+                <a:latin typeface="Calibri"/>
+              </a:rPr>
+              <a:t>É tipo quando a gente pensa 'já achei a resposta, posso parar por aqui' — só que em assembly.</a:t>
+            </a:r>
+          </a:p>
+        </p:txBody>
+      </p:sp>
+      <p:sp>
+        <p:nvSpPr>
+          <p:cNvPr id="9" name="TextBox 8"/>
           <p:cNvSpPr txBox="1"/>
           <p:nvPr/>
         </p:nvSpPr>
@@ -9909,7 +9689,7 @@
       </p:sp>
       <p:sp>
         <p:nvSpPr>
-          <p:cNvPr id="9" name="TextBox 8"/>
+          <p:cNvPr id="10" name="TextBox 9"/>
           <p:cNvSpPr txBox="1"/>
           <p:nvPr/>
         </p:nvSpPr>

</xml_diff>